<commit_message>
Agrega fuente y autor del dataset (Kaggle)
</commit_message>
<xml_diff>
--- a/reports/TP1_Grupo2_Presentacion.pptx
+++ b/reports/TP1_Grupo2_Presentacion.pptx
@@ -118,18 +118,18 @@
   <p:extLst>
     <p:ext uri="{521415D9-36F7-43E2-AB2F-B90AF26B5E84}">
       <p14:sectionLst xmlns:p14="http://schemas.microsoft.com/office/powerpoint/2010/main">
-        <p14:section name="Inicio" id="{15e0e1bd-fd90-5422-6198-60d438af6ba1}">
+        <p14:section name="Inicio" id="{7ad20fc4-2f7b-5974-f10d-bce9bdc6f527}">
           <p14:sldIdLst>
             <p14:sldId id="256"/>
           </p14:sldIdLst>
         </p14:section>
-        <p14:section name="Problema y datos" id="{c7024e69-349f-18f6-f9bc-dadb3a0a4c22}">
+        <p14:section name="Problema y datos" id="{c6162d96-fbd3-fd3c-bd3a-f7786de36c6a}">
           <p14:sldIdLst>
             <p14:sldId id="257"/>
             <p14:sldId id="258"/>
           </p14:sldIdLst>
         </p14:section>
-        <p14:section name="EDA" id="{0f6a40b5-4ce5-4acf-8c65-49041f7b9b56}">
+        <p14:section name="EDA" id="{48350ffc-2309-521e-2ebd-32f1d326083f}">
           <p14:sldIdLst>
             <p14:sldId id="259"/>
             <p14:sldId id="260"/>
@@ -137,19 +137,19 @@
             <p14:sldId id="262"/>
           </p14:sldIdLst>
         </p14:section>
-        <p14:section name="Preparación" id="{ba94f602-39bb-b35b-da21-e1dd8e2d0521}">
+        <p14:section name="Preparación" id="{45991deb-d8f1-30b5-bd19-3690964054e3}">
           <p14:sldIdLst>
             <p14:sldId id="263"/>
             <p14:sldId id="264"/>
           </p14:sldIdLst>
         </p14:section>
-        <p14:section name="Modelos" id="{9bc6197c-8b56-42aa-9a96-e6d759d6912e}">
+        <p14:section name="Modelos" id="{78dc3025-0d0b-deba-17fd-264711bb0fb1}">
           <p14:sldIdLst>
             <p14:sldId id="265"/>
             <p14:sldId id="266"/>
           </p14:sldIdLst>
         </p14:section>
-        <p14:section name="Cierre" id="{784b9a01-7066-ebc3-9b8b-ddcee8df9e85}">
+        <p14:section name="Cierre" id="{3a54b6a6-6c45-a49a-5579-726da887f335}">
           <p14:sldIdLst>
             <p14:sldId id="267"/>
           </p14:sldIdLst>
@@ -7256,7 +7256,7 @@
                   <a:schemeClr val="tx1"/>
                 </a:solidFill>
               </a:rPr>
-              <a:t>Kaggle – Thyroid Cancer Risk Prediction Dataset (uso académico).</a:t>
+              <a:t>Kaggle – Thyroid Cancer Risk Dataset (B. Chirumamilla, 2025), uso académico.</a:t>
             </a:r>
             <a:endParaRPr lang="en-US" sz="1400" dirty="0"/>
           </a:p>

</xml_diff>